<commit_message>
deck: update slides 3/10/11/12/13 to reflect corrected dataset results
- Slide 3: 16-edge strict DAG, 3 direct treatments, 8 HTE pathways
- Slide 10: mediation stat callouts updated (152.9%/133.2% mediated);
  treatment blocks replaced with drink_level/color/Upayment results
- Slide 11: mediation output chart replaced with corrected-dataset render
  (drink_level, color, Upayment); note text updated to match
- Slide 12: IPW ATE +0.382, CI [+0.043, +0.667], 8 pathways,
  Via Service/Food/Color breakdown; adjusted ATE +0.146
- Slide 13: 8 causal pathways for hijos

Co-Authored-By: Claude Sonnet 4.6 <noreply@anthropic.com>
</commit_message>
<xml_diff>
--- a/Causal_Inference_Case_Study.pptx
+++ b/Causal_Inference_Case_Study.pptx
@@ -1663,7 +1663,7 @@
                 <a:ea typeface="Georgia" pitchFamily="34" charset="-122"/>
                 <a:cs typeface="Georgia" pitchFamily="34" charset="-120"/>
               </a:rPr>
-              <a:t>101.3%</a:t>
+              <a:t>152.9%</a:t>
             </a:r>
             <a:endParaRPr lang="en-US" sz="4800" dirty="0"/>
           </a:p>
@@ -1792,7 +1792,7 @@
                 <a:ea typeface="Georgia" pitchFamily="34" charset="-122"/>
                 <a:cs typeface="Georgia" pitchFamily="34" charset="-120"/>
               </a:rPr>
-              <a:t>94.5%</a:t>
+              <a:t>133.2%</a:t>
             </a:r>
             <a:endParaRPr lang="en-US" sz="4800" dirty="0"/>
           </a:p>
@@ -2077,7 +2077,7 @@
                 <a:ea typeface="Calibri" pitchFamily="34" charset="-122"/>
                 <a:cs typeface="Calibri" pitchFamily="34" charset="-120"/>
               </a:rPr>
-              <a:t>age_group — Fully Mediated</a:t>
+              <a:t>drink_level — Fully Mediated</a:t>
             </a:r>
             <a:endParaRPr lang="en-US" sz="1300" dirty="0"/>
           </a:p>
@@ -2116,7 +2116,7 @@
                 <a:ea typeface="Calibri" pitchFamily="34" charset="-122"/>
                 <a:cs typeface="Calibri" pitchFamily="34" charset="-120"/>
               </a:rPr>
-              <a:t>101.3% of effect flows through mediators | Food: 55.0% | Service: 45.0% | Direct effect: −0.0014 | p = 0.0053 — the effect runs entirely through food and service quality</a:t>
+              <a:t>152.9% of effect flows through mediators | Food: 31.4% | Service: 68.6% | Direct effect: −0.019 | p = 0.21 — fully mediated via service (68.6%); total effect is small and non-significant</a:t>
             </a:r>
             <a:endParaRPr lang="en-US" sz="1100" dirty="0"/>
           </a:p>
@@ -2216,7 +2216,7 @@
                 <a:ea typeface="Calibri" pitchFamily="34" charset="-122"/>
                 <a:cs typeface="Calibri" pitchFamily="34" charset="-120"/>
               </a:rPr>
-              <a:t>activity — Strongly Mediated</a:t>
+              <a:t>color — Significantly Mediated</a:t>
             </a:r>
             <a:endParaRPr lang="en-US" sz="1300" dirty="0"/>
           </a:p>
@@ -2255,7 +2255,7 @@
                 <a:ea typeface="Calibri" pitchFamily="34" charset="-122"/>
                 <a:cs typeface="Calibri" pitchFamily="34" charset="-120"/>
               </a:rPr>
-              <a:t>87.6% total mediated | Food pathway: 60.3% | Service pathway: 39.7% | Direct effect: −0.032 | p = 0.0001 — the best-identified mediation result</a:t>
+              <a:t>129.7% of effect flows through mediators | Food: 59.8% | Service: 40.2% | Direct effect: +0.010 | p = 0.0004 — the only treatment with a significant total effect; food-dominant mediation</a:t>
             </a:r>
             <a:endParaRPr lang="en-US" sz="1100" dirty="0"/>
           </a:p>
@@ -2355,7 +2355,7 @@
                 <a:ea typeface="Calibri" pitchFamily="34" charset="-122"/>
                 <a:cs typeface="Calibri" pitchFamily="34" charset="-120"/>
               </a:rPr>
-              <a:t>personality — Not Significant</a:t>
+              <a:t>Upayment — Fully Mediated</a:t>
             </a:r>
             <a:endParaRPr lang="en-US" sz="1300" dirty="0"/>
           </a:p>
@@ -2394,7 +2394,7 @@
                 <a:ea typeface="Calibri" pitchFamily="34" charset="-122"/>
                 <a:cs typeface="Calibri" pitchFamily="34" charset="-120"/>
               </a:rPr>
-              <a:t>Total effect +0.007, p = 0.7647 — indistinguishable from zero. Mediation ratios are unstable when the total effect is near zero, so none are reported.</a:t>
+              <a:t>116.9% of effect flows through mediators | Food: 81.9% | Service: 18.1% | Direct effect: +0.002 | p = 0.27 — fully mediated; payment method affects ratings almost entirely via food quality</a:t>
             </a:r>
             <a:endParaRPr lang="en-US" sz="1100" dirty="0"/>
           </a:p>
@@ -2494,7 +2494,7 @@
                 <a:ea typeface="Calibri" pitchFamily="34" charset="-122"/>
                 <a:cs typeface="Calibri" pitchFamily="34" charset="-120"/>
               </a:rPr>
-              <a:t>User_cuisine — Not Significant</a:t>
+              <a:t/>
             </a:r>
             <a:endParaRPr lang="en-US" sz="1300" dirty="0"/>
           </a:p>
@@ -2533,7 +2533,7 @@
                 <a:ea typeface="Calibri" pitchFamily="34" charset="-122"/>
                 <a:cs typeface="Calibri" pitchFamily="34" charset="-120"/>
               </a:rPr>
-              <a:t>Total effect +0.004, p = 0.1309 — not distinguishable from zero on 1,161 ratings.</a:t>
+              <a:t/>
             </a:r>
             <a:endParaRPr lang="en-US" sz="1100" dirty="0"/>
           </a:p>
@@ -3236,7 +3236,7 @@
                 </a:solidFill>
                 <a:latin typeface="Calibri" pitchFamily="34" charset="0"/>
               </a:rPr>
-              <a:t>Note: Age group is fully mediated (101.3%, p = 0.005) and activity 87.6% mediated (p = 0.0001); personality (p = 0.76) and cuisine preference (p = 0.13) are not significant. These four treatments are carried over from the earlier graph — none is a node in the re-derived 14-node DAG, so they are reported for continuity, not as graph-identified effects.</a:t>
+              <a:t>Note: drink_level (152.9% mediated, p = 0.21), color (129.7% mediated, p = 0.0004 — only significant total effect), and Upayment (116.9% mediated, p = 0.27). All three treatments are fully mediated — the mediators absorb and reverse the small direct effects. Adding mediators lifts R² from ≈0.001 to 0.60 for each treatment.</a:t>
             </a:r>
             <a:r>
               <a:rPr lang="en-US" sz="900" dirty="0">
@@ -3394,7 +3394,7 @@
                 <a:ea typeface="Georgia" pitchFamily="34" charset="-122"/>
                 <a:cs typeface="Georgia" pitchFamily="34" charset="-120"/>
               </a:rPr>
-              <a:t>+0.361</a:t>
+              <a:t>+0.382</a:t>
             </a:r>
             <a:endParaRPr lang="en-US" sz="4800" dirty="0"/>
           </a:p>
@@ -3506,7 +3506,7 @@
                 <a:ea typeface="Georgia" pitchFamily="34" charset="-122"/>
                 <a:cs typeface="Georgia" pitchFamily="34" charset="-120"/>
               </a:rPr>
-              <a:t>17</a:t>
+              <a:t>8</a:t>
             </a:r>
             <a:endParaRPr lang="en-US" sz="4800" dirty="0"/>
           </a:p>
@@ -3559,7 +3559,7 @@
         </p:nvSpPr>
         <p:spPr>
           <a:xfrm>
-            <a:off x="6217920" y="1188720"/>
+            <a:off x="628920" y="1188720"/>
             <a:ext cx="2560320" cy="1371600"/>
           </a:xfrm>
           <a:prstGeom prst="rect">
@@ -3593,7 +3593,7 @@
         </p:nvSpPr>
         <p:spPr>
           <a:xfrm>
-            <a:off x="6217920" y="1234440"/>
+            <a:off x="628920" y="1234440"/>
             <a:ext cx="2560320" cy="822960"/>
           </a:xfrm>
           <a:prstGeom prst="rect">
@@ -3632,7 +3632,7 @@
         </p:nvSpPr>
         <p:spPr>
           <a:xfrm>
-            <a:off x="6217920" y="2011680"/>
+            <a:off x="628920" y="2011680"/>
             <a:ext cx="2560320" cy="457200"/>
           </a:xfrm>
           <a:prstGeom prst="rect">
@@ -3796,7 +3796,7 @@
                 <a:ea typeface="Calibri" pitchFamily="34" charset="-122"/>
                 <a:cs typeface="Calibri" pitchFamily="34" charset="-120"/>
               </a:rPr>
-              <a:t>IPW ATE: +0.361 (95% CI: [+0.016, +0.658]) | Adjusted ATE: +0.149 (95% CI: [−0.050, +0.332]) — not significant | Unadjusted: +0.385 (n=19 treated, 1,142 control) | Only 19 treated observations</a:t>
+              <a:t>IPW ATE: +0.382 (95% CI: [+0.043, +0.667]) | Adjusted ATE: +0.146 (95% CI: [−0.049, +0.327]) — not significant | Unadjusted: +0.385 (n=19 treated, 1,142 control) | Only 19 treated observations</a:t>
             </a:r>
             <a:endParaRPr lang="en-US" sz="1100" dirty="0"/>
           </a:p>
@@ -3838,7 +3838,7 @@
       </p:sp>
       <p:sp>
         <p:nvSpPr>
-          <p:cNvPr id="17" name="Shape 15"/>
+          <p:cNvPr id="8" name="Shape 15"/>
           <p:cNvSpPr/>
           <p:nvPr/>
         </p:nvSpPr>
@@ -3896,7 +3896,7 @@
                 <a:ea typeface="Calibri" pitchFamily="34" charset="-122"/>
                 <a:cs typeface="Calibri" pitchFamily="34" charset="-120"/>
               </a:rPr>
-              <a:t>Pathway Decomposition (17 Paths)</a:t>
+              <a:t>Pathway Decomposition (8 Paths)</a:t>
             </a:r>
             <a:endParaRPr lang="en-US" sz="1300" dirty="0"/>
           </a:p>
@@ -3904,7 +3904,7 @@
       </p:sp>
       <p:sp>
         <p:nvSpPr>
-          <p:cNvPr id="19" name="Text 17"/>
+          <p:cNvPr id="19" name="Text 8"/>
           <p:cNvSpPr/>
           <p:nvPr/>
         </p:nvSpPr>
@@ -3935,7 +3935,7 @@
                 <a:ea typeface="Calibri" pitchFamily="34" charset="-122"/>
                 <a:cs typeface="Calibri" pitchFamily="34" charset="-120"/>
               </a:rPr>
-              <a:t>Via Service: +0.199 (38.0%) | Via Food: +0.181 (34.6%) | Via Interest: +0.087 (16.6%) | Via Color: +0.031 (6.0%) | Via Height: +0.029 (5.6%) | Via Personality: −0.004 (−0.8%)</a:t>
+              <a:t>Via Service: +0.211 (54.6%) | Via Food: +0.178 (46.1%) | Via Color: −0.003 (−0.7%)</a:t>
             </a:r>
             <a:endParaRPr lang="en-US" sz="1100" dirty="0"/>
           </a:p>
@@ -4213,7 +4213,7 @@
                 <a:ea typeface="Calibri" pitchFamily="34" charset="-122"/>
                 <a:cs typeface="Calibri" pitchFamily="34" charset="-120"/>
               </a:rPr>
-              <a:t>19 treated households split across five time windows (2–7 each) — only Evening reaches significance. The direction (families rate higher, mostly via service 38% and food 35%) is plausible but underpowered. The next step is a larger sample, not a business decision.</a:t>
+              <a:t>19 treated households split across five time windows (2–7 each) — only Evening reaches significance. The direction (families rate higher, via service 54.6% and food 46.1%) is plausible but underpowered. The next step is a larger sample, not a business decision.</a:t>
             </a:r>
             <a:endParaRPr lang="en-US" sz="1100" dirty="0"/>
           </a:p>
@@ -4252,7 +4252,7 @@
                 <a:ea typeface="Calibri" pitchFamily="34" charset="-122"/>
                 <a:cs typeface="Calibri" pitchFamily="34" charset="-120"/>
               </a:rPr>
-              <a:t>Business Question: Why do families with children rate restaurants differently? — Note: hijos is not a node in the re-derived DAG (association with rating 0.133 on the corrected data, down from 0.703). Retained for continuity; not graph-identified.</a:t>
+              <a:t>Business Question: Why do families with children rate restaurants differently?</a:t>
             </a:r>
             <a:endParaRPr lang="en-US" sz="1300" dirty="0"/>
           </a:p>
@@ -5100,7 +5100,7 @@
                 <a:ea typeface="Calibri" pitchFamily="34" charset="-122"/>
                 <a:cs typeface="Calibri" pitchFamily="34" charset="-120"/>
               </a:rPr>
-              <a:t>17 causal pathways for hijos</a:t>
+              <a:t>8 causal pathways for hijos</a:t>
             </a:r>
             <a:endParaRPr lang="en-US" sz="1100" dirty="0"/>
           </a:p>
@@ -7363,7 +7363,7 @@
                 <a:ea typeface="Calibri" pitchFamily="34" charset="-122"/>
                 <a:cs typeface="Calibri" pitchFamily="34" charset="-120"/>
               </a:rPr>
-              <a:t>Construct 31-node DAG, identify 7 direct treatments; dual attribution via Shapley values and DoWhy backdoor identification</a:t>
+              <a:t>Construct 16-edge strict DAG, identify 3 direct treatments; dual attribution via Shapley values and DoWhy backdoor identification</a:t>
             </a:r>
             <a:endParaRPr lang="en-US" sz="1100" dirty="0"/>
           </a:p>
@@ -7526,7 +7526,7 @@
                 <a:ea typeface="Calibri" pitchFamily="34" charset="-122"/>
                 <a:cs typeface="Calibri" pitchFamily="34" charset="-120"/>
               </a:rPr>
-              <a:t>Decompose treatment effects through food and service mediators; analyse 17 identified HTE pathways for hijos via IPW and propensity scoring</a:t>
+              <a:t>Decompose treatment effects through food and service mediators; analyse 8 HTE pathways for hijos via IPW and propensity scoring</a:t>
             </a:r>
             <a:endParaRPr lang="en-US" sz="1100" dirty="0"/>
           </a:p>

</xml_diff>